<commit_message>
PowerPoint export: keep list indent once; sturdier column widths
Lists kept the ul padding both as box offset and as bullet margin, so
bullets sat 18px right of the PDF. Column widths now come from the row
with the most cells, splitting spanned cells, instead of failing when
every row has a colspan.

Co-Authored-By: Claude Opus 5.5 <noreply@anthropic.com>
</commit_message>
<xml_diff>
--- a/docs/slides/simex/fiji-aa-simulation-exercise.pptx
+++ b/docs/slides/simex/fiji-aa-simulation-exercise.pptx
@@ -21252,8 +21252,8 @@
         </p:nvSpPr>
         <p:spPr>
           <a:xfrm>
-            <a:off x="518054" y="1730640"/>
-            <a:ext cx="4210583" cy="2316162"/>
+            <a:off x="365654" y="1730640"/>
+            <a:ext cx="4367555" cy="2316162"/>
           </a:xfrm>
           <a:prstGeom prst="rect">
             <a:avLst/>

</xml_diff>